<commit_message>
De-AI-ify UI styling, strip emoji clutter, and replace non-ego jargon with plain English
</commit_message>
<xml_diff>
--- a/Safe_Road_AI_Review1_Presentation.pptx
+++ b/Safe_Road_AI_Review1_Presentation.pptx
@@ -4129,7 +4129,7 @@
               </a:defRPr>
             </a:pPr>
             <a:r>
-              <a:t>Gap 1: Non-Ego Crash False Alarms (Bao et al. [2])</a:t>
+              <a:t>Gap 1: Adjacent-Lane Crash False Alarms (Bao et al. [2])</a:t>
             </a:r>
           </a:p>
           <a:p>
@@ -5258,7 +5258,7 @@
                         </a:defRPr>
                       </a:pPr>
                       <a:r>
-                        <a:t>Evaluates real camera degradation and tests 699 non-ego crash events.</a:t>
+                        <a:t>Evaluates real camera degradation and tests 699 adjacent-lane crash events.</a:t>
                       </a:r>
                     </a:p>
                   </a:txBody>
@@ -6644,7 +6644,7 @@
                         </a:defRPr>
                       </a:pPr>
                       <a:r>
-                        <a:t>Non-ego crash panic!</a:t>
+                        <a:t>Adjacent crash false alarms!</a:t>
                       </a:r>
                     </a:p>
                   </a:txBody>
@@ -7362,7 +7362,7 @@
               </a:defRPr>
             </a:pPr>
             <a:r>
-              <a:t>2. Discovered and resolved the Non-Ego Crash Problem (camera panicking on other vehicles crashes, causing 71.4% false alarms in CCD benchmark).</a:t>
+              <a:t>2. Discovered and resolved the Adjacent-Lane Collision Problem (camera panicking on other vehicles crashes, causing 71.4% false alarms in CCD benchmark).</a:t>
             </a:r>
           </a:p>
           <a:p>
@@ -9534,7 +9534,7 @@
               </a:defRPr>
             </a:pPr>
             <a:r>
-              <a:t>• The 'Non-Ego Collision' Catastrophe: When two vehicles crash ahead in an adjacent lane, a camera-only system detects visual collision and panics (71.4% False Alarm Rate in CCD real dashcam benchmark), even though the host vehicle is 100% unharmed!</a:t>
+              <a:t>• Adjacent-Lane Collision False Alarms: When two vehicles crash ahead in an adjacent lane, a camera-only system detects visual collision and panics (71.4% False Alarm Rate in CCD real dashcam benchmark), even though the host vehicle is 100% unharmed!</a:t>
             </a:r>
           </a:p>
           <a:p>
@@ -12496,7 +12496,7 @@
                         </a:defRPr>
                       </a:pPr>
                       <a:r>
-                        <a:t>High False Alarm Rate on non-ego crashes; blinded by night headlight glare.</a:t>
+                        <a:t>High False Alarm Rate on adjacent-lane crashes; blinded by night headlight glare.</a:t>
                       </a:r>
                     </a:p>
                   </a:txBody>
@@ -12520,7 +12520,7 @@
                         </a:defRPr>
                       </a:pPr>
                       <a:r>
-                        <a:t>We cross-verify video with 50 Hz phone IMU; non-ego crashes have zero IMU shock and are discarded!</a:t>
+                        <a:t>We cross-verify video with 50 Hz phone IMU; adjacent crashes have zero IMU shock and are discarded!</a:t>
                       </a:r>
                     </a:p>
                   </a:txBody>

</xml_diff>